<commit_message>
Finish ROBOSANT decks with PUDU robot photos and zip bundle
Embed product images on cover, lineup, model, package and CTA slides. Add a zip of all four restaurant and hotel pitches.

Co-authored-by: Musobek0809 <Musobek0809@users.noreply.github.com>
</commit_message>
<xml_diff>
--- a/presentations/ROBOSANT_Mehmonxona_RU.pptx
+++ b/presentations/ROBOSANT_Mehmonxona_RU.pptx
@@ -3242,6 +3242,50 @@
         </p:nvSpPr>
         <p:spPr>
           <a:xfrm>
+            <a:off x="7818120" y="0"/>
+            <a:ext cx="4379976" cy="5989320"/>
+          </a:xfrm>
+          <a:prstGeom prst="rect">
+            <a:avLst/>
+          </a:prstGeom>
+          <a:solidFill>
+            <a:srgbClr val="E8F3FC"/>
+          </a:solidFill>
+          <a:ln>
+            <a:noFill/>
+          </a:ln>
+          <a:effectLst/>
+        </p:spPr>
+        <p:style>
+          <a:lnRef idx="1">
+            <a:schemeClr val="accent1"/>
+          </a:lnRef>
+          <a:fillRef idx="3">
+            <a:schemeClr val="accent1"/>
+          </a:fillRef>
+          <a:effectRef idx="2">
+            <a:schemeClr val="accent1"/>
+          </a:effectRef>
+          <a:fontRef idx="minor">
+            <a:schemeClr val="lt1"/>
+          </a:fontRef>
+        </p:style>
+        <p:txBody>
+          <a:bodyPr rtlCol="0" anchor="ctr"/>
+          <a:lstStyle/>
+          <a:p>
+            <a:pPr algn="ctr"/>
+          </a:p>
+        </p:txBody>
+      </p:sp>
+      <p:sp>
+        <p:nvSpPr>
+          <p:cNvPr id="6" name="Rectangle 5"/>
+          <p:cNvSpPr/>
+          <p:nvPr/>
+        </p:nvSpPr>
+        <p:spPr>
+          <a:xfrm>
             <a:off x="0" y="5989320"/>
             <a:ext cx="12191695" cy="868680"/>
           </a:xfrm>
@@ -3278,16 +3322,40 @@
           </a:p>
         </p:txBody>
       </p:sp>
-      <p:sp>
-        <p:nvSpPr>
-          <p:cNvPr id="6" name="TextBox 5"/>
+      <p:pic>
+        <p:nvPicPr>
+          <p:cNvPr id="7" name="Picture 6" descr="flash.png"/>
+          <p:cNvPicPr>
+            <a:picLocks noChangeAspect="1"/>
+          </p:cNvPicPr>
+          <p:nvPr/>
+        </p:nvPicPr>
+        <p:blipFill>
+          <a:blip r:embed="rId2"/>
+          <a:stretch>
+            <a:fillRect/>
+          </a:stretch>
+        </p:blipFill>
+        <p:spPr>
+          <a:xfrm>
+            <a:off x="8092440" y="320040"/>
+            <a:ext cx="3058853" cy="5440680"/>
+          </a:xfrm>
+          <a:prstGeom prst="rect">
+            <a:avLst/>
+          </a:prstGeom>
+        </p:spPr>
+      </p:pic>
+      <p:sp>
+        <p:nvSpPr>
+          <p:cNvPr id="8" name="TextBox 7"/>
           <p:cNvSpPr txBox="1"/>
           <p:nvPr/>
         </p:nvSpPr>
         <p:spPr>
           <a:xfrm>
             <a:off x="640080" y="411480"/>
-            <a:ext cx="10972800" cy="320040"/>
+            <a:ext cx="6949440" cy="320040"/>
           </a:xfrm>
           <a:prstGeom prst="rect">
             <a:avLst/>
@@ -3315,14 +3383,14 @@
       </p:sp>
       <p:sp>
         <p:nvSpPr>
-          <p:cNvPr id="7" name="TextBox 6"/>
-          <p:cNvSpPr txBox="1"/>
-          <p:nvPr/>
-        </p:nvSpPr>
-        <p:spPr>
-          <a:xfrm>
-            <a:off x="640080" y="914400"/>
-            <a:ext cx="10972800" cy="1005840"/>
+          <p:cNvPr id="9" name="TextBox 8"/>
+          <p:cNvSpPr txBox="1"/>
+          <p:nvPr/>
+        </p:nvSpPr>
+        <p:spPr>
+          <a:xfrm>
+            <a:off x="640080" y="868680"/>
+            <a:ext cx="6949440" cy="1051560"/>
           </a:xfrm>
           <a:prstGeom prst="rect">
             <a:avLst/>
@@ -3335,7 +3403,7 @@
           <a:p>
             <a:pPr algn="l"/>
             <a:r>
-              <a:rPr sz="5400" b="1">
+              <a:rPr sz="4800" b="1">
                 <a:solidFill>
                   <a:srgbClr val="0B3A6A"/>
                 </a:solidFill>
@@ -3350,14 +3418,14 @@
       </p:sp>
       <p:sp>
         <p:nvSpPr>
-          <p:cNvPr id="8" name="TextBox 7"/>
-          <p:cNvSpPr txBox="1"/>
-          <p:nvPr/>
-        </p:nvSpPr>
-        <p:spPr>
-          <a:xfrm>
-            <a:off x="640080" y="1965960"/>
-            <a:ext cx="10515600" cy="640080"/>
+          <p:cNvPr id="10" name="TextBox 9"/>
+          <p:cNvSpPr txBox="1"/>
+          <p:nvPr/>
+        </p:nvSpPr>
+        <p:spPr>
+          <a:xfrm>
+            <a:off x="640080" y="2011680"/>
+            <a:ext cx="6949440" cy="777240"/>
           </a:xfrm>
           <a:prstGeom prst="rect">
             <a:avLst/>
@@ -3370,7 +3438,7 @@
           <a:p>
             <a:pPr algn="l"/>
             <a:r>
-              <a:rPr sz="2000" b="0">
+              <a:rPr sz="1800" b="0">
                 <a:solidFill>
                   <a:srgbClr val="1C2E45"/>
                 </a:solidFill>
@@ -3385,14 +3453,14 @@
       </p:sp>
       <p:sp>
         <p:nvSpPr>
-          <p:cNvPr id="9" name="Rounded Rectangle 8"/>
+          <p:cNvPr id="11" name="Rounded Rectangle 10"/>
           <p:cNvSpPr/>
           <p:nvPr/>
         </p:nvSpPr>
         <p:spPr>
           <a:xfrm>
-            <a:off x="640080" y="2788920"/>
-            <a:ext cx="10789920" cy="640080"/>
+            <a:off x="640080" y="2880360"/>
+            <a:ext cx="6949440" cy="868680"/>
           </a:xfrm>
           <a:prstGeom prst="roundRect">
             <a:avLst>
@@ -3433,14 +3501,14 @@
       </p:sp>
       <p:sp>
         <p:nvSpPr>
-          <p:cNvPr id="10" name="TextBox 9"/>
-          <p:cNvSpPr txBox="1"/>
-          <p:nvPr/>
-        </p:nvSpPr>
-        <p:spPr>
-          <a:xfrm>
-            <a:off x="822960" y="2907792"/>
-            <a:ext cx="10424160" cy="457200"/>
+          <p:cNvPr id="12" name="TextBox 11"/>
+          <p:cNvSpPr txBox="1"/>
+          <p:nvPr/>
+        </p:nvSpPr>
+        <p:spPr>
+          <a:xfrm>
+            <a:off x="777240" y="2999232"/>
+            <a:ext cx="6675120" cy="685800"/>
           </a:xfrm>
           <a:prstGeom prst="rect">
             <a:avLst/>
@@ -3453,7 +3521,7 @@
           <a:p>
             <a:pPr algn="l"/>
             <a:r>
-              <a:rPr sz="1800" b="1">
+              <a:rPr sz="1600" b="1">
                 <a:solidFill>
                   <a:srgbClr val="0B3A6A"/>
                 </a:solidFill>
@@ -3468,14 +3536,14 @@
       </p:sp>
       <p:sp>
         <p:nvSpPr>
-          <p:cNvPr id="11" name="TextBox 10"/>
-          <p:cNvSpPr txBox="1"/>
-          <p:nvPr/>
-        </p:nvSpPr>
-        <p:spPr>
-          <a:xfrm>
-            <a:off x="640080" y="3657600"/>
-            <a:ext cx="10789920" cy="1188720"/>
+          <p:cNvPr id="13" name="TextBox 12"/>
+          <p:cNvSpPr txBox="1"/>
+          <p:nvPr/>
+        </p:nvSpPr>
+        <p:spPr>
+          <a:xfrm>
+            <a:off x="640080" y="3886200"/>
+            <a:ext cx="6949440" cy="1737360"/>
           </a:xfrm>
           <a:prstGeom prst="rect">
             <a:avLst/>
@@ -3488,7 +3556,7 @@
           <a:p>
             <a:pPr algn="l"/>
             <a:r>
-              <a:rPr sz="2000" b="0">
+              <a:rPr sz="1800" b="0">
                 <a:solidFill>
                   <a:srgbClr val="5A6E84"/>
                 </a:solidFill>
@@ -3503,7 +3571,7 @@
       </p:sp>
       <p:sp>
         <p:nvSpPr>
-          <p:cNvPr id="12" name="TextBox 11"/>
+          <p:cNvPr id="14" name="TextBox 13"/>
           <p:cNvSpPr txBox="1"/>
           <p:nvPr/>
         </p:nvSpPr>
@@ -7340,7 +7408,7 @@
         <p:spPr>
           <a:xfrm>
             <a:off x="411480" y="2560320"/>
-            <a:ext cx="11338560" cy="3749039"/>
+            <a:ext cx="8595360" cy="3749039"/>
           </a:xfrm>
           <a:prstGeom prst="roundRect">
             <a:avLst>
@@ -7387,8 +7455,8 @@
         </p:nvSpPr>
         <p:spPr>
           <a:xfrm>
-            <a:off x="731520" y="2788920"/>
-            <a:ext cx="10698480" cy="3291840"/>
+            <a:off x="640080" y="2743200"/>
+            <a:ext cx="8138160" cy="3383280"/>
           </a:xfrm>
           <a:prstGeom prst="rect">
             <a:avLst/>
@@ -7407,7 +7475,7 @@
               </a:spcAft>
             </a:pPr>
             <a:r>
-              <a:rPr sz="1700" b="0">
+              <a:rPr sz="1600" b="0">
                 <a:solidFill>
                   <a:srgbClr val="1C2E45"/>
                 </a:solidFill>
@@ -7425,7 +7493,7 @@
               </a:spcAft>
             </a:pPr>
             <a:r>
-              <a:rPr sz="1700" b="0">
+              <a:rPr sz="1600" b="0">
                 <a:solidFill>
                   <a:srgbClr val="1C2E45"/>
                 </a:solidFill>
@@ -7443,7 +7511,7 @@
               </a:spcAft>
             </a:pPr>
             <a:r>
-              <a:rPr sz="1700" b="0">
+              <a:rPr sz="1600" b="0">
                 <a:solidFill>
                   <a:srgbClr val="1C2E45"/>
                 </a:solidFill>
@@ -7461,7 +7529,7 @@
               </a:spcAft>
             </a:pPr>
             <a:r>
-              <a:rPr sz="1700" b="0">
+              <a:rPr sz="1600" b="0">
                 <a:solidFill>
                   <a:srgbClr val="1C2E45"/>
                 </a:solidFill>
@@ -7479,7 +7547,7 @@
               </a:spcAft>
             </a:pPr>
             <a:r>
-              <a:rPr sz="1700" b="0">
+              <a:rPr sz="1600" b="0">
                 <a:solidFill>
                   <a:srgbClr val="1C2E45"/>
                 </a:solidFill>
@@ -7497,7 +7565,7 @@
               </a:spcAft>
             </a:pPr>
             <a:r>
-              <a:rPr sz="1700" b="0">
+              <a:rPr sz="1600" b="0">
                 <a:solidFill>
                   <a:srgbClr val="1C2E45"/>
                 </a:solidFill>
@@ -7510,6 +7578,78 @@
           </a:p>
         </p:txBody>
       </p:sp>
+      <p:sp>
+        <p:nvSpPr>
+          <p:cNvPr id="23" name="Rounded Rectangle 22"/>
+          <p:cNvSpPr/>
+          <p:nvPr/>
+        </p:nvSpPr>
+        <p:spPr>
+          <a:xfrm>
+            <a:off x="9144000" y="2560320"/>
+            <a:ext cx="2606040" cy="3749039"/>
+          </a:xfrm>
+          <a:prstGeom prst="roundRect">
+            <a:avLst>
+              <a:gd name="adj" fmla="val 8000"/>
+            </a:avLst>
+          </a:prstGeom>
+          <a:solidFill>
+            <a:srgbClr val="E8F3FC"/>
+          </a:solidFill>
+          <a:ln w="15875">
+            <a:solidFill>
+              <a:srgbClr val="C5D8EC"/>
+            </a:solidFill>
+          </a:ln>
+          <a:effectLst/>
+        </p:spPr>
+        <p:style>
+          <a:lnRef idx="1">
+            <a:schemeClr val="accent1"/>
+          </a:lnRef>
+          <a:fillRef idx="3">
+            <a:schemeClr val="accent1"/>
+          </a:fillRef>
+          <a:effectRef idx="2">
+            <a:schemeClr val="accent1"/>
+          </a:effectRef>
+          <a:fontRef idx="minor">
+            <a:schemeClr val="lt1"/>
+          </a:fontRef>
+        </p:style>
+        <p:txBody>
+          <a:bodyPr rtlCol="0" anchor="ctr"/>
+          <a:lstStyle/>
+          <a:p>
+            <a:pPr algn="ctr"/>
+          </a:p>
+        </p:txBody>
+      </p:sp>
+      <p:pic>
+        <p:nvPicPr>
+          <p:cNvPr id="24" name="Picture 23" descr="flash.png"/>
+          <p:cNvPicPr>
+            <a:picLocks noChangeAspect="1"/>
+          </p:cNvPicPr>
+          <p:nvPr/>
+        </p:nvPicPr>
+        <p:blipFill>
+          <a:blip r:embed="rId2"/>
+          <a:stretch>
+            <a:fillRect/>
+          </a:stretch>
+        </p:blipFill>
+        <p:spPr>
+          <a:xfrm>
+            <a:off x="9281160" y="2697480"/>
+            <a:ext cx="1953553" cy="3474720"/>
+          </a:xfrm>
+          <a:prstGeom prst="rect">
+            <a:avLst/>
+          </a:prstGeom>
+        </p:spPr>
+      </p:pic>
     </p:spTree>
   </p:cSld>
   <p:clrMapOvr>
@@ -7668,8 +7808,8 @@
         </p:nvSpPr>
         <p:spPr>
           <a:xfrm>
-            <a:off x="640080" y="640080"/>
-            <a:ext cx="10972800" cy="1097280"/>
+            <a:off x="640080" y="502920"/>
+            <a:ext cx="7863840" cy="1097280"/>
           </a:xfrm>
           <a:prstGeom prst="rect">
             <a:avLst/>
@@ -7682,7 +7822,7 @@
           <a:p>
             <a:pPr algn="l"/>
             <a:r>
-              <a:rPr sz="2800" b="1">
+              <a:rPr sz="2600" b="1">
                 <a:solidFill>
                   <a:srgbClr val="0B3A6A"/>
                 </a:solidFill>
@@ -7703,8 +7843,8 @@
         </p:nvSpPr>
         <p:spPr>
           <a:xfrm>
-            <a:off x="640080" y="1828800"/>
-            <a:ext cx="10972800" cy="640080"/>
+            <a:off x="640080" y="1600200"/>
+            <a:ext cx="7863840" cy="640080"/>
           </a:xfrm>
           <a:prstGeom prst="rect">
             <a:avLst/>
@@ -7717,7 +7857,7 @@
           <a:p>
             <a:pPr algn="l"/>
             <a:r>
-              <a:rPr sz="1800" b="0">
+              <a:rPr sz="1600" b="0">
                 <a:solidFill>
                   <a:srgbClr val="5A6E84"/>
                 </a:solidFill>
@@ -7730,16 +7870,40 @@
           </a:p>
         </p:txBody>
       </p:sp>
-      <p:sp>
-        <p:nvSpPr>
-          <p:cNvPr id="7" name="Rounded Rectangle 6"/>
+      <p:pic>
+        <p:nvPicPr>
+          <p:cNvPr id="7" name="Picture 6" descr="flash.png"/>
+          <p:cNvPicPr>
+            <a:picLocks noChangeAspect="1"/>
+          </p:cNvPicPr>
+          <p:nvPr/>
+        </p:nvPicPr>
+        <p:blipFill>
+          <a:blip r:embed="rId2"/>
+          <a:stretch>
+            <a:fillRect/>
+          </a:stretch>
+        </p:blipFill>
+        <p:spPr>
+          <a:xfrm>
+            <a:off x="8686800" y="365760"/>
+            <a:ext cx="1310937" cy="2331720"/>
+          </a:xfrm>
+          <a:prstGeom prst="rect">
+            <a:avLst/>
+          </a:prstGeom>
+        </p:spPr>
+      </p:pic>
+      <p:sp>
+        <p:nvSpPr>
+          <p:cNvPr id="8" name="Rounded Rectangle 7"/>
           <p:cNvSpPr/>
           <p:nvPr/>
         </p:nvSpPr>
         <p:spPr>
           <a:xfrm>
-            <a:off x="640080" y="2743200"/>
-            <a:ext cx="2697480" cy="1234440"/>
+            <a:off x="640080" y="2468880"/>
+            <a:ext cx="2697480" cy="1097280"/>
           </a:xfrm>
           <a:prstGeom prst="roundRect">
             <a:avLst>
@@ -7780,13 +7944,13 @@
       </p:sp>
       <p:sp>
         <p:nvSpPr>
-          <p:cNvPr id="8" name="TextBox 7"/>
-          <p:cNvSpPr txBox="1"/>
-          <p:nvPr/>
-        </p:nvSpPr>
-        <p:spPr>
-          <a:xfrm>
-            <a:off x="731520" y="3108960"/>
+          <p:cNvPr id="9" name="TextBox 8"/>
+          <p:cNvSpPr txBox="1"/>
+          <p:nvPr/>
+        </p:nvSpPr>
+        <p:spPr>
+          <a:xfrm>
+            <a:off x="731520" y="2788920"/>
             <a:ext cx="2514600" cy="548640"/>
           </a:xfrm>
           <a:prstGeom prst="rect">
@@ -7815,14 +7979,14 @@
       </p:sp>
       <p:sp>
         <p:nvSpPr>
-          <p:cNvPr id="9" name="Rounded Rectangle 8"/>
+          <p:cNvPr id="10" name="Rounded Rectangle 9"/>
           <p:cNvSpPr/>
           <p:nvPr/>
         </p:nvSpPr>
         <p:spPr>
           <a:xfrm>
-            <a:off x="3474720" y="2743200"/>
-            <a:ext cx="2697480" cy="1234440"/>
+            <a:off x="3474720" y="2468880"/>
+            <a:ext cx="2697480" cy="1097280"/>
           </a:xfrm>
           <a:prstGeom prst="roundRect">
             <a:avLst>
@@ -7863,13 +8027,13 @@
       </p:sp>
       <p:sp>
         <p:nvSpPr>
-          <p:cNvPr id="10" name="TextBox 9"/>
-          <p:cNvSpPr txBox="1"/>
-          <p:nvPr/>
-        </p:nvSpPr>
-        <p:spPr>
-          <a:xfrm>
-            <a:off x="3566160" y="3108960"/>
+          <p:cNvPr id="11" name="TextBox 10"/>
+          <p:cNvSpPr txBox="1"/>
+          <p:nvPr/>
+        </p:nvSpPr>
+        <p:spPr>
+          <a:xfrm>
+            <a:off x="3566160" y="2788920"/>
             <a:ext cx="2514600" cy="548640"/>
           </a:xfrm>
           <a:prstGeom prst="rect">
@@ -7898,14 +8062,14 @@
       </p:sp>
       <p:sp>
         <p:nvSpPr>
-          <p:cNvPr id="11" name="Rounded Rectangle 10"/>
+          <p:cNvPr id="12" name="Rounded Rectangle 11"/>
           <p:cNvSpPr/>
           <p:nvPr/>
         </p:nvSpPr>
         <p:spPr>
           <a:xfrm>
-            <a:off x="6309360" y="2743200"/>
-            <a:ext cx="2697480" cy="1234440"/>
+            <a:off x="6309360" y="2468880"/>
+            <a:ext cx="2697480" cy="1097280"/>
           </a:xfrm>
           <a:prstGeom prst="roundRect">
             <a:avLst>
@@ -7946,13 +8110,13 @@
       </p:sp>
       <p:sp>
         <p:nvSpPr>
-          <p:cNvPr id="12" name="TextBox 11"/>
-          <p:cNvSpPr txBox="1"/>
-          <p:nvPr/>
-        </p:nvSpPr>
-        <p:spPr>
-          <a:xfrm>
-            <a:off x="6400800" y="3108960"/>
+          <p:cNvPr id="13" name="TextBox 12"/>
+          <p:cNvSpPr txBox="1"/>
+          <p:nvPr/>
+        </p:nvSpPr>
+        <p:spPr>
+          <a:xfrm>
+            <a:off x="6400800" y="2788920"/>
             <a:ext cx="2514600" cy="548640"/>
           </a:xfrm>
           <a:prstGeom prst="rect">
@@ -7981,14 +8145,14 @@
       </p:sp>
       <p:sp>
         <p:nvSpPr>
-          <p:cNvPr id="13" name="Rounded Rectangle 12"/>
+          <p:cNvPr id="14" name="Rounded Rectangle 13"/>
           <p:cNvSpPr/>
           <p:nvPr/>
         </p:nvSpPr>
         <p:spPr>
           <a:xfrm>
-            <a:off x="9144000" y="2743200"/>
-            <a:ext cx="2697480" cy="1234440"/>
+            <a:off x="9144000" y="2468880"/>
+            <a:ext cx="2697480" cy="1097280"/>
           </a:xfrm>
           <a:prstGeom prst="roundRect">
             <a:avLst>
@@ -8029,13 +8193,13 @@
       </p:sp>
       <p:sp>
         <p:nvSpPr>
-          <p:cNvPr id="14" name="TextBox 13"/>
-          <p:cNvSpPr txBox="1"/>
-          <p:nvPr/>
-        </p:nvSpPr>
-        <p:spPr>
-          <a:xfrm>
-            <a:off x="9235440" y="3108960"/>
+          <p:cNvPr id="15" name="TextBox 14"/>
+          <p:cNvSpPr txBox="1"/>
+          <p:nvPr/>
+        </p:nvSpPr>
+        <p:spPr>
+          <a:xfrm>
+            <a:off x="9235440" y="2788920"/>
             <a:ext cx="2514600" cy="548640"/>
           </a:xfrm>
           <a:prstGeom prst="rect">
@@ -8064,13 +8228,13 @@
       </p:sp>
       <p:sp>
         <p:nvSpPr>
-          <p:cNvPr id="15" name="Rounded Rectangle 14"/>
+          <p:cNvPr id="16" name="Rounded Rectangle 15"/>
           <p:cNvSpPr/>
           <p:nvPr/>
         </p:nvSpPr>
         <p:spPr>
           <a:xfrm>
-            <a:off x="640080" y="4297680"/>
+            <a:off x="640080" y="3840480"/>
             <a:ext cx="10972800" cy="1051560"/>
           </a:xfrm>
           <a:prstGeom prst="roundRect">
@@ -8110,13 +8274,13 @@
       </p:sp>
       <p:sp>
         <p:nvSpPr>
-          <p:cNvPr id="16" name="TextBox 15"/>
-          <p:cNvSpPr txBox="1"/>
-          <p:nvPr/>
-        </p:nvSpPr>
-        <p:spPr>
-          <a:xfrm>
-            <a:off x="640080" y="4572000"/>
+          <p:cNvPr id="17" name="TextBox 16"/>
+          <p:cNvSpPr txBox="1"/>
+          <p:nvPr/>
+        </p:nvSpPr>
+        <p:spPr>
+          <a:xfrm>
+            <a:off x="640080" y="4114800"/>
             <a:ext cx="10972800" cy="548640"/>
           </a:xfrm>
           <a:prstGeom prst="rect">
@@ -8145,14 +8309,14 @@
       </p:sp>
       <p:sp>
         <p:nvSpPr>
-          <p:cNvPr id="17" name="TextBox 16"/>
-          <p:cNvSpPr txBox="1"/>
-          <p:nvPr/>
-        </p:nvSpPr>
-        <p:spPr>
-          <a:xfrm>
-            <a:off x="640080" y="5760720"/>
-            <a:ext cx="10972800" cy="457200"/>
+          <p:cNvPr id="18" name="TextBox 17"/>
+          <p:cNvSpPr txBox="1"/>
+          <p:nvPr/>
+        </p:nvSpPr>
+        <p:spPr>
+          <a:xfrm>
+            <a:off x="640080" y="5120640"/>
+            <a:ext cx="10972800" cy="822960"/>
           </a:xfrm>
           <a:prstGeom prst="rect">
             <a:avLst/>
@@ -10121,8 +10285,8 @@
         </p:nvSpPr>
         <p:spPr>
           <a:xfrm>
-            <a:off x="365760" y="1371600"/>
-            <a:ext cx="2174991" cy="4937760"/>
+            <a:off x="365760" y="1325880"/>
+            <a:ext cx="2174991" cy="5029200"/>
           </a:xfrm>
           <a:prstGeom prst="roundRect">
             <a:avLst>
@@ -10169,8 +10333,8 @@
         </p:nvSpPr>
         <p:spPr>
           <a:xfrm>
-            <a:off x="365760" y="1371600"/>
-            <a:ext cx="2174991" cy="109728"/>
+            <a:off x="365760" y="1325880"/>
+            <a:ext cx="2174991" cy="91440"/>
           </a:xfrm>
           <a:prstGeom prst="rect">
             <a:avLst/>
@@ -10213,8 +10377,8 @@
         </p:nvSpPr>
         <p:spPr>
           <a:xfrm>
-            <a:off x="475488" y="1645920"/>
-            <a:ext cx="1955535" cy="1005840"/>
+            <a:off x="438912" y="1463040"/>
+            <a:ext cx="2028687" cy="640080"/>
           </a:xfrm>
           <a:prstGeom prst="rect">
             <a:avLst/>
@@ -10227,7 +10391,7 @@
           <a:p>
             <a:pPr algn="ctr"/>
             <a:r>
-              <a:rPr sz="1500" b="1">
+              <a:rPr sz="1300" b="1">
                 <a:solidFill>
                   <a:srgbClr val="0B3A6A"/>
                 </a:solidFill>
@@ -10240,16 +10404,40 @@
           </a:p>
         </p:txBody>
       </p:sp>
-      <p:sp>
-        <p:nvSpPr>
-          <p:cNvPr id="13" name="TextBox 12"/>
-          <p:cNvSpPr txBox="1"/>
-          <p:nvPr/>
-        </p:nvSpPr>
-        <p:spPr>
-          <a:xfrm>
-            <a:off x="475488" y="2743200"/>
-            <a:ext cx="1955535" cy="3200400"/>
+      <p:pic>
+        <p:nvPicPr>
+          <p:cNvPr id="13" name="Picture 12" descr="flash.png"/>
+          <p:cNvPicPr>
+            <a:picLocks noChangeAspect="1"/>
+          </p:cNvPicPr>
+          <p:nvPr/>
+        </p:nvPicPr>
+        <p:blipFill>
+          <a:blip r:embed="rId2"/>
+          <a:stretch>
+            <a:fillRect/>
+          </a:stretch>
+        </p:blipFill>
+        <p:spPr>
+          <a:xfrm>
+            <a:off x="566928" y="2057400"/>
+            <a:ext cx="1208118" cy="2148840"/>
+          </a:xfrm>
+          <a:prstGeom prst="rect">
+            <a:avLst/>
+          </a:prstGeom>
+        </p:spPr>
+      </p:pic>
+      <p:sp>
+        <p:nvSpPr>
+          <p:cNvPr id="14" name="TextBox 13"/>
+          <p:cNvSpPr txBox="1"/>
+          <p:nvPr/>
+        </p:nvSpPr>
+        <p:spPr>
+          <a:xfrm>
+            <a:off x="457200" y="4251960"/>
+            <a:ext cx="1992111" cy="1920240"/>
           </a:xfrm>
           <a:prstGeom prst="rect">
             <a:avLst/>
@@ -10264,7 +10452,7 @@
           <a:p>
             <a:pPr algn="ctr"/>
             <a:r>
-              <a:rPr sz="1300" b="0">
+              <a:rPr sz="1200" b="0">
                 <a:solidFill>
                   <a:srgbClr val="1C2E45"/>
                 </a:solidFill>
@@ -10281,14 +10469,14 @@
       </p:sp>
       <p:sp>
         <p:nvSpPr>
-          <p:cNvPr id="14" name="Rounded Rectangle 13"/>
+          <p:cNvPr id="15" name="Rounded Rectangle 14"/>
           <p:cNvSpPr/>
           <p:nvPr/>
         </p:nvSpPr>
         <p:spPr>
           <a:xfrm>
-            <a:off x="2687055" y="1371600"/>
-            <a:ext cx="2174991" cy="4937760"/>
+            <a:off x="2687055" y="1325880"/>
+            <a:ext cx="2174991" cy="5029200"/>
           </a:xfrm>
           <a:prstGeom prst="roundRect">
             <a:avLst>
@@ -10329,14 +10517,14 @@
       </p:sp>
       <p:sp>
         <p:nvSpPr>
-          <p:cNvPr id="15" name="Rectangle 14"/>
+          <p:cNvPr id="16" name="Rectangle 15"/>
           <p:cNvSpPr/>
           <p:nvPr/>
         </p:nvSpPr>
         <p:spPr>
           <a:xfrm>
-            <a:off x="2687055" y="1371600"/>
-            <a:ext cx="2174991" cy="109728"/>
+            <a:off x="2687055" y="1325880"/>
+            <a:ext cx="2174991" cy="91440"/>
           </a:xfrm>
           <a:prstGeom prst="rect">
             <a:avLst/>
@@ -10373,14 +10561,14 @@
       </p:sp>
       <p:sp>
         <p:nvSpPr>
-          <p:cNvPr id="16" name="TextBox 15"/>
-          <p:cNvSpPr txBox="1"/>
-          <p:nvPr/>
-        </p:nvSpPr>
-        <p:spPr>
-          <a:xfrm>
-            <a:off x="2796783" y="1645920"/>
-            <a:ext cx="1955535" cy="1005840"/>
+          <p:cNvPr id="17" name="TextBox 16"/>
+          <p:cNvSpPr txBox="1"/>
+          <p:nvPr/>
+        </p:nvSpPr>
+        <p:spPr>
+          <a:xfrm>
+            <a:off x="2760207" y="1463040"/>
+            <a:ext cx="2028687" cy="640080"/>
           </a:xfrm>
           <a:prstGeom prst="rect">
             <a:avLst/>
@@ -10393,7 +10581,7 @@
           <a:p>
             <a:pPr algn="ctr"/>
             <a:r>
-              <a:rPr sz="1500" b="1">
+              <a:rPr sz="1300" b="1">
                 <a:solidFill>
                   <a:srgbClr val="0B3A6A"/>
                 </a:solidFill>
@@ -10406,16 +10594,40 @@
           </a:p>
         </p:txBody>
       </p:sp>
-      <p:sp>
-        <p:nvSpPr>
-          <p:cNvPr id="17" name="TextBox 16"/>
-          <p:cNvSpPr txBox="1"/>
-          <p:nvPr/>
-        </p:nvSpPr>
-        <p:spPr>
-          <a:xfrm>
-            <a:off x="2796783" y="2743200"/>
-            <a:ext cx="1955535" cy="3200400"/>
+      <p:pic>
+        <p:nvPicPr>
+          <p:cNvPr id="18" name="Picture 17" descr="bella.png"/>
+          <p:cNvPicPr>
+            <a:picLocks noChangeAspect="1"/>
+          </p:cNvPicPr>
+          <p:nvPr/>
+        </p:nvPicPr>
+        <p:blipFill>
+          <a:blip r:embed="rId3"/>
+          <a:stretch>
+            <a:fillRect/>
+          </a:stretch>
+        </p:blipFill>
+        <p:spPr>
+          <a:xfrm>
+            <a:off x="2888223" y="2057400"/>
+            <a:ext cx="1790700" cy="2148840"/>
+          </a:xfrm>
+          <a:prstGeom prst="rect">
+            <a:avLst/>
+          </a:prstGeom>
+        </p:spPr>
+      </p:pic>
+      <p:sp>
+        <p:nvSpPr>
+          <p:cNvPr id="19" name="TextBox 18"/>
+          <p:cNvSpPr txBox="1"/>
+          <p:nvPr/>
+        </p:nvSpPr>
+        <p:spPr>
+          <a:xfrm>
+            <a:off x="2778495" y="4251960"/>
+            <a:ext cx="1992111" cy="1920240"/>
           </a:xfrm>
           <a:prstGeom prst="rect">
             <a:avLst/>
@@ -10430,7 +10642,7 @@
           <a:p>
             <a:pPr algn="ctr"/>
             <a:r>
-              <a:rPr sz="1300" b="0">
+              <a:rPr sz="1200" b="0">
                 <a:solidFill>
                   <a:srgbClr val="1C2E45"/>
                 </a:solidFill>
@@ -10447,14 +10659,14 @@
       </p:sp>
       <p:sp>
         <p:nvSpPr>
-          <p:cNvPr id="18" name="Rounded Rectangle 17"/>
+          <p:cNvPr id="20" name="Rounded Rectangle 19"/>
           <p:cNvSpPr/>
           <p:nvPr/>
         </p:nvSpPr>
         <p:spPr>
           <a:xfrm>
-            <a:off x="5008351" y="1371600"/>
-            <a:ext cx="2174991" cy="4937760"/>
+            <a:off x="5008351" y="1325880"/>
+            <a:ext cx="2174991" cy="5029200"/>
           </a:xfrm>
           <a:prstGeom prst="roundRect">
             <a:avLst>
@@ -10495,14 +10707,14 @@
       </p:sp>
       <p:sp>
         <p:nvSpPr>
-          <p:cNvPr id="19" name="Rectangle 18"/>
+          <p:cNvPr id="21" name="Rectangle 20"/>
           <p:cNvSpPr/>
           <p:nvPr/>
         </p:nvSpPr>
         <p:spPr>
           <a:xfrm>
-            <a:off x="5008351" y="1371600"/>
-            <a:ext cx="2174991" cy="109728"/>
+            <a:off x="5008351" y="1325880"/>
+            <a:ext cx="2174991" cy="91440"/>
           </a:xfrm>
           <a:prstGeom prst="rect">
             <a:avLst/>
@@ -10539,14 +10751,14 @@
       </p:sp>
       <p:sp>
         <p:nvSpPr>
-          <p:cNvPr id="20" name="TextBox 19"/>
-          <p:cNvSpPr txBox="1"/>
-          <p:nvPr/>
-        </p:nvSpPr>
-        <p:spPr>
-          <a:xfrm>
-            <a:off x="5118079" y="1645920"/>
-            <a:ext cx="1955535" cy="1005840"/>
+          <p:cNvPr id="22" name="TextBox 21"/>
+          <p:cNvSpPr txBox="1"/>
+          <p:nvPr/>
+        </p:nvSpPr>
+        <p:spPr>
+          <a:xfrm>
+            <a:off x="5081503" y="1463040"/>
+            <a:ext cx="2028687" cy="640080"/>
           </a:xfrm>
           <a:prstGeom prst="rect">
             <a:avLst/>
@@ -10559,7 +10771,7 @@
           <a:p>
             <a:pPr algn="ctr"/>
             <a:r>
-              <a:rPr sz="1500" b="1">
+              <a:rPr sz="1300" b="1">
                 <a:solidFill>
                   <a:srgbClr val="0B3A6A"/>
                 </a:solidFill>
@@ -10572,16 +10784,40 @@
           </a:p>
         </p:txBody>
       </p:sp>
-      <p:sp>
-        <p:nvSpPr>
-          <p:cNvPr id="21" name="TextBox 20"/>
-          <p:cNvSpPr txBox="1"/>
-          <p:nvPr/>
-        </p:nvSpPr>
-        <p:spPr>
-          <a:xfrm>
-            <a:off x="5118079" y="2743200"/>
-            <a:ext cx="1955535" cy="3200400"/>
+      <p:pic>
+        <p:nvPicPr>
+          <p:cNvPr id="23" name="Picture 22" descr="ketty.png"/>
+          <p:cNvPicPr>
+            <a:picLocks noChangeAspect="1"/>
+          </p:cNvPicPr>
+          <p:nvPr/>
+        </p:nvPicPr>
+        <p:blipFill>
+          <a:blip r:embed="rId4"/>
+          <a:stretch>
+            <a:fillRect/>
+          </a:stretch>
+        </p:blipFill>
+        <p:spPr>
+          <a:xfrm>
+            <a:off x="5209519" y="2057400"/>
+            <a:ext cx="1637558" cy="2148840"/>
+          </a:xfrm>
+          <a:prstGeom prst="rect">
+            <a:avLst/>
+          </a:prstGeom>
+        </p:spPr>
+      </p:pic>
+      <p:sp>
+        <p:nvSpPr>
+          <p:cNvPr id="24" name="TextBox 23"/>
+          <p:cNvSpPr txBox="1"/>
+          <p:nvPr/>
+        </p:nvSpPr>
+        <p:spPr>
+          <a:xfrm>
+            <a:off x="5099791" y="4251960"/>
+            <a:ext cx="1992111" cy="1920240"/>
           </a:xfrm>
           <a:prstGeom prst="rect">
             <a:avLst/>
@@ -10596,7 +10832,7 @@
           <a:p>
             <a:pPr algn="ctr"/>
             <a:r>
-              <a:rPr sz="1300" b="0">
+              <a:rPr sz="1200" b="0">
                 <a:solidFill>
                   <a:srgbClr val="1C2E45"/>
                 </a:solidFill>
@@ -10613,14 +10849,14 @@
       </p:sp>
       <p:sp>
         <p:nvSpPr>
-          <p:cNvPr id="22" name="Rounded Rectangle 21"/>
+          <p:cNvPr id="25" name="Rounded Rectangle 24"/>
           <p:cNvSpPr/>
           <p:nvPr/>
         </p:nvSpPr>
         <p:spPr>
           <a:xfrm>
-            <a:off x="7329647" y="1371600"/>
-            <a:ext cx="2174991" cy="4937760"/>
+            <a:off x="7329647" y="1325880"/>
+            <a:ext cx="2174991" cy="5029200"/>
           </a:xfrm>
           <a:prstGeom prst="roundRect">
             <a:avLst>
@@ -10661,14 +10897,14 @@
       </p:sp>
       <p:sp>
         <p:nvSpPr>
-          <p:cNvPr id="23" name="Rectangle 22"/>
+          <p:cNvPr id="26" name="Rectangle 25"/>
           <p:cNvSpPr/>
           <p:nvPr/>
         </p:nvSpPr>
         <p:spPr>
           <a:xfrm>
-            <a:off x="7329647" y="1371600"/>
-            <a:ext cx="2174991" cy="109728"/>
+            <a:off x="7329647" y="1325880"/>
+            <a:ext cx="2174991" cy="91440"/>
           </a:xfrm>
           <a:prstGeom prst="rect">
             <a:avLst/>
@@ -10705,14 +10941,14 @@
       </p:sp>
       <p:sp>
         <p:nvSpPr>
-          <p:cNvPr id="24" name="TextBox 23"/>
-          <p:cNvSpPr txBox="1"/>
-          <p:nvPr/>
-        </p:nvSpPr>
-        <p:spPr>
-          <a:xfrm>
-            <a:off x="7439375" y="1645920"/>
-            <a:ext cx="1955535" cy="1005840"/>
+          <p:cNvPr id="27" name="TextBox 26"/>
+          <p:cNvSpPr txBox="1"/>
+          <p:nvPr/>
+        </p:nvSpPr>
+        <p:spPr>
+          <a:xfrm>
+            <a:off x="7402799" y="1463040"/>
+            <a:ext cx="2028687" cy="640080"/>
           </a:xfrm>
           <a:prstGeom prst="rect">
             <a:avLst/>
@@ -10725,7 +10961,7 @@
           <a:p>
             <a:pPr algn="ctr"/>
             <a:r>
-              <a:rPr sz="1500" b="1">
+              <a:rPr sz="1300" b="1">
                 <a:solidFill>
                   <a:srgbClr val="0B3A6A"/>
                 </a:solidFill>
@@ -10738,16 +10974,40 @@
           </a:p>
         </p:txBody>
       </p:sp>
-      <p:sp>
-        <p:nvSpPr>
-          <p:cNvPr id="25" name="TextBox 24"/>
-          <p:cNvSpPr txBox="1"/>
-          <p:nvPr/>
-        </p:nvSpPr>
-        <p:spPr>
-          <a:xfrm>
-            <a:off x="7439375" y="2743200"/>
-            <a:ext cx="1955535" cy="3200400"/>
+      <p:pic>
+        <p:nvPicPr>
+          <p:cNvPr id="28" name="Picture 27" descr="pudu2.png"/>
+          <p:cNvPicPr>
+            <a:picLocks noChangeAspect="1"/>
+          </p:cNvPicPr>
+          <p:nvPr/>
+        </p:nvPicPr>
+        <p:blipFill>
+          <a:blip r:embed="rId5"/>
+          <a:stretch>
+            <a:fillRect/>
+          </a:stretch>
+        </p:blipFill>
+        <p:spPr>
+          <a:xfrm>
+            <a:off x="7530815" y="2057400"/>
+            <a:ext cx="1651260" cy="2148840"/>
+          </a:xfrm>
+          <a:prstGeom prst="rect">
+            <a:avLst/>
+          </a:prstGeom>
+        </p:spPr>
+      </p:pic>
+      <p:sp>
+        <p:nvSpPr>
+          <p:cNvPr id="29" name="TextBox 28"/>
+          <p:cNvSpPr txBox="1"/>
+          <p:nvPr/>
+        </p:nvSpPr>
+        <p:spPr>
+          <a:xfrm>
+            <a:off x="7421087" y="4251960"/>
+            <a:ext cx="1992111" cy="1920240"/>
           </a:xfrm>
           <a:prstGeom prst="rect">
             <a:avLst/>
@@ -10762,7 +11022,7 @@
           <a:p>
             <a:pPr algn="ctr"/>
             <a:r>
-              <a:rPr sz="1300" b="0">
+              <a:rPr sz="1200" b="0">
                 <a:solidFill>
                   <a:srgbClr val="1C2E45"/>
                 </a:solidFill>
@@ -10778,14 +11038,14 @@
       </p:sp>
       <p:sp>
         <p:nvSpPr>
-          <p:cNvPr id="26" name="Rounded Rectangle 25"/>
+          <p:cNvPr id="30" name="Rounded Rectangle 29"/>
           <p:cNvSpPr/>
           <p:nvPr/>
         </p:nvSpPr>
         <p:spPr>
           <a:xfrm>
-            <a:off x="9650943" y="1371600"/>
-            <a:ext cx="2174991" cy="4937760"/>
+            <a:off x="9650943" y="1325880"/>
+            <a:ext cx="2174991" cy="5029200"/>
           </a:xfrm>
           <a:prstGeom prst="roundRect">
             <a:avLst>
@@ -10826,14 +11086,14 @@
       </p:sp>
       <p:sp>
         <p:nvSpPr>
-          <p:cNvPr id="27" name="Rectangle 26"/>
+          <p:cNvPr id="31" name="Rectangle 30"/>
           <p:cNvSpPr/>
           <p:nvPr/>
         </p:nvSpPr>
         <p:spPr>
           <a:xfrm>
-            <a:off x="9650943" y="1371600"/>
-            <a:ext cx="2174991" cy="109728"/>
+            <a:off x="9650943" y="1325880"/>
+            <a:ext cx="2174991" cy="91440"/>
           </a:xfrm>
           <a:prstGeom prst="rect">
             <a:avLst/>
@@ -10870,14 +11130,14 @@
       </p:sp>
       <p:sp>
         <p:nvSpPr>
-          <p:cNvPr id="28" name="TextBox 27"/>
-          <p:cNvSpPr txBox="1"/>
-          <p:nvPr/>
-        </p:nvSpPr>
-        <p:spPr>
-          <a:xfrm>
-            <a:off x="9760671" y="1645920"/>
-            <a:ext cx="1955535" cy="1005840"/>
+          <p:cNvPr id="32" name="TextBox 31"/>
+          <p:cNvSpPr txBox="1"/>
+          <p:nvPr/>
+        </p:nvSpPr>
+        <p:spPr>
+          <a:xfrm>
+            <a:off x="9724095" y="1463040"/>
+            <a:ext cx="2028687" cy="640080"/>
           </a:xfrm>
           <a:prstGeom prst="rect">
             <a:avLst/>
@@ -10890,7 +11150,7 @@
           <a:p>
             <a:pPr algn="ctr"/>
             <a:r>
-              <a:rPr sz="1500" b="1">
+              <a:rPr sz="1300" b="1">
                 <a:solidFill>
                   <a:srgbClr val="0B3A6A"/>
                 </a:solidFill>
@@ -10903,16 +11163,40 @@
           </a:p>
         </p:txBody>
       </p:sp>
-      <p:sp>
-        <p:nvSpPr>
-          <p:cNvPr id="29" name="TextBox 28"/>
-          <p:cNvSpPr txBox="1"/>
-          <p:nvPr/>
-        </p:nvSpPr>
-        <p:spPr>
-          <a:xfrm>
-            <a:off x="9760671" y="2743200"/>
-            <a:ext cx="1955535" cy="3200400"/>
+      <p:pic>
+        <p:nvPicPr>
+          <p:cNvPr id="33" name="Picture 32" descr="cc1.png"/>
+          <p:cNvPicPr>
+            <a:picLocks noChangeAspect="1"/>
+          </p:cNvPicPr>
+          <p:nvPr/>
+        </p:nvPicPr>
+        <p:blipFill>
+          <a:blip r:embed="rId6"/>
+          <a:stretch>
+            <a:fillRect/>
+          </a:stretch>
+        </p:blipFill>
+        <p:spPr>
+          <a:xfrm>
+            <a:off x="9852111" y="2057400"/>
+            <a:ext cx="1208118" cy="2148840"/>
+          </a:xfrm>
+          <a:prstGeom prst="rect">
+            <a:avLst/>
+          </a:prstGeom>
+        </p:spPr>
+      </p:pic>
+      <p:sp>
+        <p:nvSpPr>
+          <p:cNvPr id="34" name="TextBox 33"/>
+          <p:cNvSpPr txBox="1"/>
+          <p:nvPr/>
+        </p:nvSpPr>
+        <p:spPr>
+          <a:xfrm>
+            <a:off x="9742383" y="4251960"/>
+            <a:ext cx="1992111" cy="1920240"/>
           </a:xfrm>
           <a:prstGeom prst="rect">
             <a:avLst/>
@@ -10927,7 +11211,7 @@
           <a:p>
             <a:pPr algn="ctr"/>
             <a:r>
-              <a:rPr sz="1300" b="0">
+              <a:rPr sz="1200" b="0">
                 <a:solidFill>
                   <a:srgbClr val="1C2E45"/>
                 </a:solidFill>
@@ -11275,8 +11559,80 @@
         </p:nvSpPr>
         <p:spPr>
           <a:xfrm>
-            <a:off x="365760" y="1280160"/>
-            <a:ext cx="6675120" cy="5074920"/>
+            <a:off x="320040" y="1234440"/>
+            <a:ext cx="3246120" cy="5120640"/>
+          </a:xfrm>
+          <a:prstGeom prst="roundRect">
+            <a:avLst>
+              <a:gd name="adj" fmla="val 8000"/>
+            </a:avLst>
+          </a:prstGeom>
+          <a:solidFill>
+            <a:srgbClr val="E8F3FC"/>
+          </a:solidFill>
+          <a:ln w="15875">
+            <a:solidFill>
+              <a:srgbClr val="C5D8EC"/>
+            </a:solidFill>
+          </a:ln>
+          <a:effectLst/>
+        </p:spPr>
+        <p:style>
+          <a:lnRef idx="1">
+            <a:schemeClr val="accent1"/>
+          </a:lnRef>
+          <a:fillRef idx="3">
+            <a:schemeClr val="accent1"/>
+          </a:fillRef>
+          <a:effectRef idx="2">
+            <a:schemeClr val="accent1"/>
+          </a:effectRef>
+          <a:fontRef idx="minor">
+            <a:schemeClr val="lt1"/>
+          </a:fontRef>
+        </p:style>
+        <p:txBody>
+          <a:bodyPr rtlCol="0" anchor="ctr"/>
+          <a:lstStyle/>
+          <a:p>
+            <a:pPr algn="ctr"/>
+          </a:p>
+        </p:txBody>
+      </p:sp>
+      <p:pic>
+        <p:nvPicPr>
+          <p:cNvPr id="11" name="Picture 10" descr="flash.png"/>
+          <p:cNvPicPr>
+            <a:picLocks noChangeAspect="1"/>
+          </p:cNvPicPr>
+          <p:nvPr/>
+        </p:nvPicPr>
+        <p:blipFill>
+          <a:blip r:embed="rId2"/>
+          <a:stretch>
+            <a:fillRect/>
+          </a:stretch>
+        </p:blipFill>
+        <p:spPr>
+          <a:xfrm>
+            <a:off x="502920" y="1371600"/>
+            <a:ext cx="2724693" cy="4846320"/>
+          </a:xfrm>
+          <a:prstGeom prst="rect">
+            <a:avLst/>
+          </a:prstGeom>
+        </p:spPr>
+      </p:pic>
+      <p:sp>
+        <p:nvSpPr>
+          <p:cNvPr id="12" name="Rounded Rectangle 11"/>
+          <p:cNvSpPr/>
+          <p:nvPr/>
+        </p:nvSpPr>
+        <p:spPr>
+          <a:xfrm>
+            <a:off x="3703320" y="1234440"/>
+            <a:ext cx="4434840" cy="5120640"/>
           </a:xfrm>
           <a:prstGeom prst="roundRect">
             <a:avLst>
@@ -11317,14 +11673,14 @@
       </p:sp>
       <p:sp>
         <p:nvSpPr>
-          <p:cNvPr id="11" name="TextBox 10"/>
-          <p:cNvSpPr txBox="1"/>
-          <p:nvPr/>
-        </p:nvSpPr>
-        <p:spPr>
-          <a:xfrm>
-            <a:off x="594360" y="1463040"/>
-            <a:ext cx="6309360" cy="4754880"/>
+          <p:cNvPr id="13" name="TextBox 12"/>
+          <p:cNvSpPr txBox="1"/>
+          <p:nvPr/>
+        </p:nvSpPr>
+        <p:spPr>
+          <a:xfrm>
+            <a:off x="3840480" y="1371600"/>
+            <a:ext cx="4160520" cy="4846320"/>
           </a:xfrm>
           <a:prstGeom prst="rect">
             <a:avLst/>
@@ -11343,7 +11699,7 @@
               </a:spcAft>
             </a:pPr>
             <a:r>
-              <a:rPr sz="1600" b="0">
+              <a:rPr sz="1300" b="0">
                 <a:solidFill>
                   <a:srgbClr val="1C2E45"/>
                 </a:solidFill>
@@ -11361,7 +11717,7 @@
               </a:spcAft>
             </a:pPr>
             <a:r>
-              <a:rPr sz="1600" b="0">
+              <a:rPr sz="1300" b="0">
                 <a:solidFill>
                   <a:srgbClr val="1C2E45"/>
                 </a:solidFill>
@@ -11379,7 +11735,7 @@
               </a:spcAft>
             </a:pPr>
             <a:r>
-              <a:rPr sz="1600" b="0">
+              <a:rPr sz="1300" b="0">
                 <a:solidFill>
                   <a:srgbClr val="1C2E45"/>
                 </a:solidFill>
@@ -11397,7 +11753,7 @@
               </a:spcAft>
             </a:pPr>
             <a:r>
-              <a:rPr sz="1600" b="0">
+              <a:rPr sz="1300" b="0">
                 <a:solidFill>
                   <a:srgbClr val="1C2E45"/>
                 </a:solidFill>
@@ -11415,7 +11771,7 @@
               </a:spcAft>
             </a:pPr>
             <a:r>
-              <a:rPr sz="1600" b="0">
+              <a:rPr sz="1300" b="0">
                 <a:solidFill>
                   <a:srgbClr val="1C2E45"/>
                 </a:solidFill>
@@ -11433,7 +11789,7 @@
               </a:spcAft>
             </a:pPr>
             <a:r>
-              <a:rPr sz="1600" b="0">
+              <a:rPr sz="1300" b="0">
                 <a:solidFill>
                   <a:srgbClr val="1C2E45"/>
                 </a:solidFill>
@@ -11451,7 +11807,7 @@
               </a:spcAft>
             </a:pPr>
             <a:r>
-              <a:rPr sz="1600" b="0">
+              <a:rPr sz="1300" b="0">
                 <a:solidFill>
                   <a:srgbClr val="1C2E45"/>
                 </a:solidFill>
@@ -11469,7 +11825,7 @@
               </a:spcAft>
             </a:pPr>
             <a:r>
-              <a:rPr sz="1600" b="0">
+              <a:rPr sz="1300" b="0">
                 <a:solidFill>
                   <a:srgbClr val="1C2E45"/>
                 </a:solidFill>
@@ -11484,14 +11840,14 @@
       </p:sp>
       <p:sp>
         <p:nvSpPr>
-          <p:cNvPr id="12" name="Rounded Rectangle 11"/>
+          <p:cNvPr id="14" name="Rounded Rectangle 13"/>
           <p:cNvSpPr/>
           <p:nvPr/>
         </p:nvSpPr>
         <p:spPr>
           <a:xfrm>
-            <a:off x="7223760" y="1280160"/>
-            <a:ext cx="2194560" cy="1143000"/>
+            <a:off x="8275320" y="1234440"/>
+            <a:ext cx="1783080" cy="1170432"/>
           </a:xfrm>
           <a:prstGeom prst="roundRect">
             <a:avLst>
@@ -11532,14 +11888,14 @@
       </p:sp>
       <p:sp>
         <p:nvSpPr>
-          <p:cNvPr id="13" name="TextBox 12"/>
-          <p:cNvSpPr txBox="1"/>
-          <p:nvPr/>
-        </p:nvSpPr>
-        <p:spPr>
-          <a:xfrm>
-            <a:off x="7315200" y="1417320"/>
-            <a:ext cx="2011680" cy="320040"/>
+          <p:cNvPr id="15" name="TextBox 14"/>
+          <p:cNvSpPr txBox="1"/>
+          <p:nvPr/>
+        </p:nvSpPr>
+        <p:spPr>
+          <a:xfrm>
+            <a:off x="8330184" y="1362456"/>
+            <a:ext cx="1673352" cy="320040"/>
           </a:xfrm>
           <a:prstGeom prst="rect">
             <a:avLst/>
@@ -11552,7 +11908,7 @@
           <a:p>
             <a:pPr algn="ctr"/>
             <a:r>
-              <a:rPr sz="1100" b="0">
+              <a:rPr sz="1000" b="0">
                 <a:solidFill>
                   <a:srgbClr val="5A6E84"/>
                 </a:solidFill>
@@ -11567,14 +11923,14 @@
       </p:sp>
       <p:sp>
         <p:nvSpPr>
-          <p:cNvPr id="14" name="TextBox 13"/>
-          <p:cNvSpPr txBox="1"/>
-          <p:nvPr/>
-        </p:nvSpPr>
-        <p:spPr>
-          <a:xfrm>
-            <a:off x="7296912" y="1737360"/>
-            <a:ext cx="2048256" cy="548640"/>
+          <p:cNvPr id="16" name="TextBox 15"/>
+          <p:cNvSpPr txBox="1"/>
+          <p:nvPr/>
+        </p:nvSpPr>
+        <p:spPr>
+          <a:xfrm>
+            <a:off x="8330184" y="1691640"/>
+            <a:ext cx="1673352" cy="594360"/>
           </a:xfrm>
           <a:prstGeom prst="rect">
             <a:avLst/>
@@ -11587,7 +11943,7 @@
           <a:p>
             <a:pPr algn="ctr"/>
             <a:r>
-              <a:rPr sz="1300" b="1">
+              <a:rPr sz="1200" b="1">
                 <a:solidFill>
                   <a:srgbClr val="0B3A6A"/>
                 </a:solidFill>
@@ -11602,14 +11958,14 @@
       </p:sp>
       <p:sp>
         <p:nvSpPr>
-          <p:cNvPr id="15" name="Rounded Rectangle 14"/>
+          <p:cNvPr id="17" name="Rounded Rectangle 16"/>
           <p:cNvSpPr/>
           <p:nvPr/>
         </p:nvSpPr>
         <p:spPr>
           <a:xfrm>
-            <a:off x="9555480" y="1280160"/>
-            <a:ext cx="2194560" cy="1143000"/>
+            <a:off x="10149839" y="1234440"/>
+            <a:ext cx="1783080" cy="1170432"/>
           </a:xfrm>
           <a:prstGeom prst="roundRect">
             <a:avLst>
@@ -11650,14 +12006,14 @@
       </p:sp>
       <p:sp>
         <p:nvSpPr>
-          <p:cNvPr id="16" name="TextBox 15"/>
-          <p:cNvSpPr txBox="1"/>
-          <p:nvPr/>
-        </p:nvSpPr>
-        <p:spPr>
-          <a:xfrm>
-            <a:off x="9646920" y="1417320"/>
-            <a:ext cx="2011680" cy="320040"/>
+          <p:cNvPr id="18" name="TextBox 17"/>
+          <p:cNvSpPr txBox="1"/>
+          <p:nvPr/>
+        </p:nvSpPr>
+        <p:spPr>
+          <a:xfrm>
+            <a:off x="10204703" y="1362456"/>
+            <a:ext cx="1673352" cy="320040"/>
           </a:xfrm>
           <a:prstGeom prst="rect">
             <a:avLst/>
@@ -11670,7 +12026,7 @@
           <a:p>
             <a:pPr algn="ctr"/>
             <a:r>
-              <a:rPr sz="1100" b="0">
+              <a:rPr sz="1000" b="0">
                 <a:solidFill>
                   <a:srgbClr val="5A6E84"/>
                 </a:solidFill>
@@ -11685,14 +12041,14 @@
       </p:sp>
       <p:sp>
         <p:nvSpPr>
-          <p:cNvPr id="17" name="TextBox 16"/>
-          <p:cNvSpPr txBox="1"/>
-          <p:nvPr/>
-        </p:nvSpPr>
-        <p:spPr>
-          <a:xfrm>
-            <a:off x="9628632" y="1737360"/>
-            <a:ext cx="2048256" cy="548640"/>
+          <p:cNvPr id="19" name="TextBox 18"/>
+          <p:cNvSpPr txBox="1"/>
+          <p:nvPr/>
+        </p:nvSpPr>
+        <p:spPr>
+          <a:xfrm>
+            <a:off x="10204703" y="1691640"/>
+            <a:ext cx="1673352" cy="594360"/>
           </a:xfrm>
           <a:prstGeom prst="rect">
             <a:avLst/>
@@ -11705,7 +12061,7 @@
           <a:p>
             <a:pPr algn="ctr"/>
             <a:r>
-              <a:rPr sz="1300" b="1">
+              <a:rPr sz="1200" b="1">
                 <a:solidFill>
                   <a:srgbClr val="0B3A6A"/>
                 </a:solidFill>
@@ -11720,14 +12076,14 @@
       </p:sp>
       <p:sp>
         <p:nvSpPr>
-          <p:cNvPr id="18" name="Rounded Rectangle 17"/>
+          <p:cNvPr id="20" name="Rounded Rectangle 19"/>
           <p:cNvSpPr/>
           <p:nvPr/>
         </p:nvSpPr>
         <p:spPr>
           <a:xfrm>
-            <a:off x="7223760" y="2542032"/>
-            <a:ext cx="2194560" cy="1143000"/>
+            <a:off x="8275320" y="2514600"/>
+            <a:ext cx="1783080" cy="1170432"/>
           </a:xfrm>
           <a:prstGeom prst="roundRect">
             <a:avLst>
@@ -11768,14 +12124,14 @@
       </p:sp>
       <p:sp>
         <p:nvSpPr>
-          <p:cNvPr id="19" name="TextBox 18"/>
-          <p:cNvSpPr txBox="1"/>
-          <p:nvPr/>
-        </p:nvSpPr>
-        <p:spPr>
-          <a:xfrm>
-            <a:off x="7315200" y="2679192"/>
-            <a:ext cx="2011680" cy="320040"/>
+          <p:cNvPr id="21" name="TextBox 20"/>
+          <p:cNvSpPr txBox="1"/>
+          <p:nvPr/>
+        </p:nvSpPr>
+        <p:spPr>
+          <a:xfrm>
+            <a:off x="8330184" y="2642616"/>
+            <a:ext cx="1673352" cy="320040"/>
           </a:xfrm>
           <a:prstGeom prst="rect">
             <a:avLst/>
@@ -11788,7 +12144,7 @@
           <a:p>
             <a:pPr algn="ctr"/>
             <a:r>
-              <a:rPr sz="1100" b="0">
+              <a:rPr sz="1000" b="0">
                 <a:solidFill>
                   <a:srgbClr val="5A6E84"/>
                 </a:solidFill>
@@ -11803,14 +12159,14 @@
       </p:sp>
       <p:sp>
         <p:nvSpPr>
-          <p:cNvPr id="20" name="TextBox 19"/>
-          <p:cNvSpPr txBox="1"/>
-          <p:nvPr/>
-        </p:nvSpPr>
-        <p:spPr>
-          <a:xfrm>
-            <a:off x="7296912" y="2999232"/>
-            <a:ext cx="2048256" cy="548640"/>
+          <p:cNvPr id="22" name="TextBox 21"/>
+          <p:cNvSpPr txBox="1"/>
+          <p:nvPr/>
+        </p:nvSpPr>
+        <p:spPr>
+          <a:xfrm>
+            <a:off x="8330184" y="2971800"/>
+            <a:ext cx="1673352" cy="594360"/>
           </a:xfrm>
           <a:prstGeom prst="rect">
             <a:avLst/>
@@ -11823,7 +12179,7 @@
           <a:p>
             <a:pPr algn="ctr"/>
             <a:r>
-              <a:rPr sz="1300" b="1">
+              <a:rPr sz="1200" b="1">
                 <a:solidFill>
                   <a:srgbClr val="0B3A6A"/>
                 </a:solidFill>
@@ -11838,14 +12194,14 @@
       </p:sp>
       <p:sp>
         <p:nvSpPr>
-          <p:cNvPr id="21" name="Rounded Rectangle 20"/>
+          <p:cNvPr id="23" name="Rounded Rectangle 22"/>
           <p:cNvSpPr/>
           <p:nvPr/>
         </p:nvSpPr>
         <p:spPr>
           <a:xfrm>
-            <a:off x="9555480" y="2542032"/>
-            <a:ext cx="2194560" cy="1143000"/>
+            <a:off x="10149839" y="2514600"/>
+            <a:ext cx="1783080" cy="1170432"/>
           </a:xfrm>
           <a:prstGeom prst="roundRect">
             <a:avLst>
@@ -11886,14 +12242,14 @@
       </p:sp>
       <p:sp>
         <p:nvSpPr>
-          <p:cNvPr id="22" name="TextBox 21"/>
-          <p:cNvSpPr txBox="1"/>
-          <p:nvPr/>
-        </p:nvSpPr>
-        <p:spPr>
-          <a:xfrm>
-            <a:off x="9646920" y="2679192"/>
-            <a:ext cx="2011680" cy="320040"/>
+          <p:cNvPr id="24" name="TextBox 23"/>
+          <p:cNvSpPr txBox="1"/>
+          <p:nvPr/>
+        </p:nvSpPr>
+        <p:spPr>
+          <a:xfrm>
+            <a:off x="10204703" y="2642616"/>
+            <a:ext cx="1673352" cy="320040"/>
           </a:xfrm>
           <a:prstGeom prst="rect">
             <a:avLst/>
@@ -11906,7 +12262,7 @@
           <a:p>
             <a:pPr algn="ctr"/>
             <a:r>
-              <a:rPr sz="1100" b="0">
+              <a:rPr sz="1000" b="0">
                 <a:solidFill>
                   <a:srgbClr val="5A6E84"/>
                 </a:solidFill>
@@ -11921,14 +12277,14 @@
       </p:sp>
       <p:sp>
         <p:nvSpPr>
-          <p:cNvPr id="23" name="TextBox 22"/>
-          <p:cNvSpPr txBox="1"/>
-          <p:nvPr/>
-        </p:nvSpPr>
-        <p:spPr>
-          <a:xfrm>
-            <a:off x="9628632" y="2999232"/>
-            <a:ext cx="2048256" cy="548640"/>
+          <p:cNvPr id="25" name="TextBox 24"/>
+          <p:cNvSpPr txBox="1"/>
+          <p:nvPr/>
+        </p:nvSpPr>
+        <p:spPr>
+          <a:xfrm>
+            <a:off x="10204703" y="2971800"/>
+            <a:ext cx="1673352" cy="594360"/>
           </a:xfrm>
           <a:prstGeom prst="rect">
             <a:avLst/>
@@ -11941,7 +12297,7 @@
           <a:p>
             <a:pPr algn="ctr"/>
             <a:r>
-              <a:rPr sz="1300" b="1">
+              <a:rPr sz="1200" b="1">
                 <a:solidFill>
                   <a:srgbClr val="0B3A6A"/>
                 </a:solidFill>
@@ -11956,14 +12312,14 @@
       </p:sp>
       <p:sp>
         <p:nvSpPr>
-          <p:cNvPr id="24" name="Rounded Rectangle 23"/>
+          <p:cNvPr id="26" name="Rounded Rectangle 25"/>
           <p:cNvSpPr/>
           <p:nvPr/>
         </p:nvSpPr>
         <p:spPr>
           <a:xfrm>
-            <a:off x="7223760" y="3803904"/>
-            <a:ext cx="2194560" cy="1143000"/>
+            <a:off x="8275320" y="3794760"/>
+            <a:ext cx="1783080" cy="1170432"/>
           </a:xfrm>
           <a:prstGeom prst="roundRect">
             <a:avLst>
@@ -12004,14 +12360,14 @@
       </p:sp>
       <p:sp>
         <p:nvSpPr>
-          <p:cNvPr id="25" name="TextBox 24"/>
-          <p:cNvSpPr txBox="1"/>
-          <p:nvPr/>
-        </p:nvSpPr>
-        <p:spPr>
-          <a:xfrm>
-            <a:off x="7315200" y="3941064"/>
-            <a:ext cx="2011680" cy="320040"/>
+          <p:cNvPr id="27" name="TextBox 26"/>
+          <p:cNvSpPr txBox="1"/>
+          <p:nvPr/>
+        </p:nvSpPr>
+        <p:spPr>
+          <a:xfrm>
+            <a:off x="8330184" y="3922776"/>
+            <a:ext cx="1673352" cy="320040"/>
           </a:xfrm>
           <a:prstGeom prst="rect">
             <a:avLst/>
@@ -12024,7 +12380,7 @@
           <a:p>
             <a:pPr algn="ctr"/>
             <a:r>
-              <a:rPr sz="1100" b="0">
+              <a:rPr sz="1000" b="0">
                 <a:solidFill>
                   <a:srgbClr val="5A6E84"/>
                 </a:solidFill>
@@ -12039,14 +12395,14 @@
       </p:sp>
       <p:sp>
         <p:nvSpPr>
-          <p:cNvPr id="26" name="TextBox 25"/>
-          <p:cNvSpPr txBox="1"/>
-          <p:nvPr/>
-        </p:nvSpPr>
-        <p:spPr>
-          <a:xfrm>
-            <a:off x="7296912" y="4261104"/>
-            <a:ext cx="2048256" cy="548640"/>
+          <p:cNvPr id="28" name="TextBox 27"/>
+          <p:cNvSpPr txBox="1"/>
+          <p:nvPr/>
+        </p:nvSpPr>
+        <p:spPr>
+          <a:xfrm>
+            <a:off x="8330184" y="4251960"/>
+            <a:ext cx="1673352" cy="594360"/>
           </a:xfrm>
           <a:prstGeom prst="rect">
             <a:avLst/>
@@ -12059,7 +12415,7 @@
           <a:p>
             <a:pPr algn="ctr"/>
             <a:r>
-              <a:rPr sz="1300" b="1">
+              <a:rPr sz="1200" b="1">
                 <a:solidFill>
                   <a:srgbClr val="0B3A6A"/>
                 </a:solidFill>
@@ -12074,14 +12430,14 @@
       </p:sp>
       <p:sp>
         <p:nvSpPr>
-          <p:cNvPr id="27" name="Rounded Rectangle 26"/>
+          <p:cNvPr id="29" name="Rounded Rectangle 28"/>
           <p:cNvSpPr/>
           <p:nvPr/>
         </p:nvSpPr>
         <p:spPr>
           <a:xfrm>
-            <a:off x="9555480" y="3803904"/>
-            <a:ext cx="2194560" cy="1143000"/>
+            <a:off x="10149839" y="3794760"/>
+            <a:ext cx="1783080" cy="1170432"/>
           </a:xfrm>
           <a:prstGeom prst="roundRect">
             <a:avLst>
@@ -12122,14 +12478,14 @@
       </p:sp>
       <p:sp>
         <p:nvSpPr>
-          <p:cNvPr id="28" name="TextBox 27"/>
-          <p:cNvSpPr txBox="1"/>
-          <p:nvPr/>
-        </p:nvSpPr>
-        <p:spPr>
-          <a:xfrm>
-            <a:off x="9646920" y="3941064"/>
-            <a:ext cx="2011680" cy="320040"/>
+          <p:cNvPr id="30" name="TextBox 29"/>
+          <p:cNvSpPr txBox="1"/>
+          <p:nvPr/>
+        </p:nvSpPr>
+        <p:spPr>
+          <a:xfrm>
+            <a:off x="10204703" y="3922776"/>
+            <a:ext cx="1673352" cy="320040"/>
           </a:xfrm>
           <a:prstGeom prst="rect">
             <a:avLst/>
@@ -12142,7 +12498,7 @@
           <a:p>
             <a:pPr algn="ctr"/>
             <a:r>
-              <a:rPr sz="1100" b="0">
+              <a:rPr sz="1000" b="0">
                 <a:solidFill>
                   <a:srgbClr val="5A6E84"/>
                 </a:solidFill>
@@ -12157,14 +12513,14 @@
       </p:sp>
       <p:sp>
         <p:nvSpPr>
-          <p:cNvPr id="29" name="TextBox 28"/>
-          <p:cNvSpPr txBox="1"/>
-          <p:nvPr/>
-        </p:nvSpPr>
-        <p:spPr>
-          <a:xfrm>
-            <a:off x="9628632" y="4261104"/>
-            <a:ext cx="2048256" cy="548640"/>
+          <p:cNvPr id="31" name="TextBox 30"/>
+          <p:cNvSpPr txBox="1"/>
+          <p:nvPr/>
+        </p:nvSpPr>
+        <p:spPr>
+          <a:xfrm>
+            <a:off x="10204703" y="4251960"/>
+            <a:ext cx="1673352" cy="594360"/>
           </a:xfrm>
           <a:prstGeom prst="rect">
             <a:avLst/>
@@ -12177,7 +12533,7 @@
           <a:p>
             <a:pPr algn="ctr"/>
             <a:r>
-              <a:rPr sz="1300" b="1">
+              <a:rPr sz="1200" b="1">
                 <a:solidFill>
                   <a:srgbClr val="0B3A6A"/>
                 </a:solidFill>
@@ -12192,14 +12548,14 @@
       </p:sp>
       <p:sp>
         <p:nvSpPr>
-          <p:cNvPr id="30" name="Rounded Rectangle 29"/>
+          <p:cNvPr id="32" name="Rounded Rectangle 31"/>
           <p:cNvSpPr/>
           <p:nvPr/>
         </p:nvSpPr>
         <p:spPr>
           <a:xfrm>
-            <a:off x="7223760" y="5065776"/>
-            <a:ext cx="2194560" cy="1143000"/>
+            <a:off x="8275320" y="5074920"/>
+            <a:ext cx="1783080" cy="1170432"/>
           </a:xfrm>
           <a:prstGeom prst="roundRect">
             <a:avLst>
@@ -12240,14 +12596,14 @@
       </p:sp>
       <p:sp>
         <p:nvSpPr>
-          <p:cNvPr id="31" name="TextBox 30"/>
-          <p:cNvSpPr txBox="1"/>
-          <p:nvPr/>
-        </p:nvSpPr>
-        <p:spPr>
-          <a:xfrm>
-            <a:off x="7315200" y="5202936"/>
-            <a:ext cx="2011680" cy="320040"/>
+          <p:cNvPr id="33" name="TextBox 32"/>
+          <p:cNvSpPr txBox="1"/>
+          <p:nvPr/>
+        </p:nvSpPr>
+        <p:spPr>
+          <a:xfrm>
+            <a:off x="8330184" y="5202936"/>
+            <a:ext cx="1673352" cy="320040"/>
           </a:xfrm>
           <a:prstGeom prst="rect">
             <a:avLst/>
@@ -12260,7 +12616,7 @@
           <a:p>
             <a:pPr algn="ctr"/>
             <a:r>
-              <a:rPr sz="1100" b="0">
+              <a:rPr sz="1000" b="0">
                 <a:solidFill>
                   <a:srgbClr val="5A6E84"/>
                 </a:solidFill>
@@ -12275,14 +12631,14 @@
       </p:sp>
       <p:sp>
         <p:nvSpPr>
-          <p:cNvPr id="32" name="TextBox 31"/>
-          <p:cNvSpPr txBox="1"/>
-          <p:nvPr/>
-        </p:nvSpPr>
-        <p:spPr>
-          <a:xfrm>
-            <a:off x="7296912" y="5522976"/>
-            <a:ext cx="2048256" cy="548640"/>
+          <p:cNvPr id="34" name="TextBox 33"/>
+          <p:cNvSpPr txBox="1"/>
+          <p:nvPr/>
+        </p:nvSpPr>
+        <p:spPr>
+          <a:xfrm>
+            <a:off x="8330184" y="5532120"/>
+            <a:ext cx="1673352" cy="594360"/>
           </a:xfrm>
           <a:prstGeom prst="rect">
             <a:avLst/>
@@ -12295,7 +12651,7 @@
           <a:p>
             <a:pPr algn="ctr"/>
             <a:r>
-              <a:rPr sz="1300" b="1">
+              <a:rPr sz="1200" b="1">
                 <a:solidFill>
                   <a:srgbClr val="0B3A6A"/>
                 </a:solidFill>
@@ -12310,14 +12666,14 @@
       </p:sp>
       <p:sp>
         <p:nvSpPr>
-          <p:cNvPr id="33" name="Rounded Rectangle 32"/>
+          <p:cNvPr id="35" name="Rounded Rectangle 34"/>
           <p:cNvSpPr/>
           <p:nvPr/>
         </p:nvSpPr>
         <p:spPr>
           <a:xfrm>
-            <a:off x="9555480" y="5065776"/>
-            <a:ext cx="2194560" cy="1143000"/>
+            <a:off x="10149839" y="5074920"/>
+            <a:ext cx="1783080" cy="1170432"/>
           </a:xfrm>
           <a:prstGeom prst="roundRect">
             <a:avLst>
@@ -12358,14 +12714,14 @@
       </p:sp>
       <p:sp>
         <p:nvSpPr>
-          <p:cNvPr id="34" name="TextBox 33"/>
-          <p:cNvSpPr txBox="1"/>
-          <p:nvPr/>
-        </p:nvSpPr>
-        <p:spPr>
-          <a:xfrm>
-            <a:off x="9646920" y="5202936"/>
-            <a:ext cx="2011680" cy="320040"/>
+          <p:cNvPr id="36" name="TextBox 35"/>
+          <p:cNvSpPr txBox="1"/>
+          <p:nvPr/>
+        </p:nvSpPr>
+        <p:spPr>
+          <a:xfrm>
+            <a:off x="10204703" y="5202936"/>
+            <a:ext cx="1673352" cy="320040"/>
           </a:xfrm>
           <a:prstGeom prst="rect">
             <a:avLst/>
@@ -12378,7 +12734,7 @@
           <a:p>
             <a:pPr algn="ctr"/>
             <a:r>
-              <a:rPr sz="1100" b="0">
+              <a:rPr sz="1000" b="0">
                 <a:solidFill>
                   <a:srgbClr val="5A6E84"/>
                 </a:solidFill>
@@ -12393,14 +12749,14 @@
       </p:sp>
       <p:sp>
         <p:nvSpPr>
-          <p:cNvPr id="35" name="TextBox 34"/>
-          <p:cNvSpPr txBox="1"/>
-          <p:nvPr/>
-        </p:nvSpPr>
-        <p:spPr>
-          <a:xfrm>
-            <a:off x="9628632" y="5522976"/>
-            <a:ext cx="2048256" cy="548640"/>
+          <p:cNvPr id="37" name="TextBox 36"/>
+          <p:cNvSpPr txBox="1"/>
+          <p:nvPr/>
+        </p:nvSpPr>
+        <p:spPr>
+          <a:xfrm>
+            <a:off x="10204703" y="5532120"/>
+            <a:ext cx="1673352" cy="594360"/>
           </a:xfrm>
           <a:prstGeom prst="rect">
             <a:avLst/>
@@ -12413,7 +12769,7 @@
           <a:p>
             <a:pPr algn="ctr"/>
             <a:r>
-              <a:rPr sz="1300" b="1">
+              <a:rPr sz="1200" b="1">
                 <a:solidFill>
                   <a:srgbClr val="0B3A6A"/>
                 </a:solidFill>
@@ -12724,8 +13080,8 @@
         </p:nvSpPr>
         <p:spPr>
           <a:xfrm>
-            <a:off x="365760" y="1325880"/>
-            <a:ext cx="5623560" cy="4937760"/>
+            <a:off x="365760" y="1280160"/>
+            <a:ext cx="5623560" cy="5074920"/>
           </a:xfrm>
           <a:prstGeom prst="roundRect">
             <a:avLst>
@@ -12764,16 +13120,40 @@
           </a:p>
         </p:txBody>
       </p:sp>
-      <p:sp>
-        <p:nvSpPr>
-          <p:cNvPr id="10" name="TextBox 9"/>
-          <p:cNvSpPr txBox="1"/>
-          <p:nvPr/>
-        </p:nvSpPr>
-        <p:spPr>
-          <a:xfrm>
-            <a:off x="530352" y="1453896"/>
-            <a:ext cx="5294376" cy="365760"/>
+      <p:pic>
+        <p:nvPicPr>
+          <p:cNvPr id="10" name="Picture 9" descr="bella.png"/>
+          <p:cNvPicPr>
+            <a:picLocks noChangeAspect="1"/>
+          </p:cNvPicPr>
+          <p:nvPr/>
+        </p:nvPicPr>
+        <p:blipFill>
+          <a:blip r:embed="rId2"/>
+          <a:stretch>
+            <a:fillRect/>
+          </a:stretch>
+        </p:blipFill>
+        <p:spPr>
+          <a:xfrm>
+            <a:off x="594360" y="1417320"/>
+            <a:ext cx="1943100" cy="2331720"/>
+          </a:xfrm>
+          <a:prstGeom prst="rect">
+            <a:avLst/>
+          </a:prstGeom>
+        </p:spPr>
+      </p:pic>
+      <p:sp>
+        <p:nvSpPr>
+          <p:cNvPr id="11" name="TextBox 10"/>
+          <p:cNvSpPr txBox="1"/>
+          <p:nvPr/>
+        </p:nvSpPr>
+        <p:spPr>
+          <a:xfrm>
+            <a:off x="2560320" y="1554480"/>
+            <a:ext cx="3200400" cy="2011680"/>
           </a:xfrm>
           <a:prstGeom prst="rect">
             <a:avLst/>
@@ -12801,14 +13181,14 @@
       </p:sp>
       <p:sp>
         <p:nvSpPr>
-          <p:cNvPr id="11" name="TextBox 10"/>
-          <p:cNvSpPr txBox="1"/>
-          <p:nvPr/>
-        </p:nvSpPr>
-        <p:spPr>
-          <a:xfrm>
-            <a:off x="530352" y="1801368"/>
-            <a:ext cx="5294376" cy="4352544"/>
+          <p:cNvPr id="12" name="TextBox 11"/>
+          <p:cNvSpPr txBox="1"/>
+          <p:nvPr/>
+        </p:nvSpPr>
+        <p:spPr>
+          <a:xfrm>
+            <a:off x="594360" y="3840480"/>
+            <a:ext cx="5166360" cy="2286000"/>
           </a:xfrm>
           <a:prstGeom prst="rect">
             <a:avLst/>
@@ -12821,9 +13201,8 @@
           </a:bodyPr>
           <a:lstStyle/>
           <a:p>
-            <a:pPr algn="l"/>
-            <a:r>
-              <a:rPr sz="1600" b="0">
+            <a:r>
+              <a:rPr sz="1500" b="0">
                 <a:solidFill>
                   <a:srgbClr val="1C2E45"/>
                 </a:solidFill>
@@ -12838,14 +13217,14 @@
       </p:sp>
       <p:sp>
         <p:nvSpPr>
-          <p:cNvPr id="12" name="Rounded Rectangle 11"/>
+          <p:cNvPr id="13" name="Rounded Rectangle 12"/>
           <p:cNvSpPr/>
           <p:nvPr/>
         </p:nvSpPr>
         <p:spPr>
           <a:xfrm>
-            <a:off x="6172200" y="1325880"/>
-            <a:ext cx="5623560" cy="4937760"/>
+            <a:off x="6172200" y="1280160"/>
+            <a:ext cx="5623560" cy="5074920"/>
           </a:xfrm>
           <a:prstGeom prst="roundRect">
             <a:avLst>
@@ -12884,16 +13263,40 @@
           </a:p>
         </p:txBody>
       </p:sp>
-      <p:sp>
-        <p:nvSpPr>
-          <p:cNvPr id="13" name="TextBox 12"/>
-          <p:cNvSpPr txBox="1"/>
-          <p:nvPr/>
-        </p:nvSpPr>
-        <p:spPr>
-          <a:xfrm>
-            <a:off x="6336792" y="1453896"/>
-            <a:ext cx="5294376" cy="365760"/>
+      <p:pic>
+        <p:nvPicPr>
+          <p:cNvPr id="14" name="Picture 13" descr="ketty.png"/>
+          <p:cNvPicPr>
+            <a:picLocks noChangeAspect="1"/>
+          </p:cNvPicPr>
+          <p:nvPr/>
+        </p:nvPicPr>
+        <p:blipFill>
+          <a:blip r:embed="rId3"/>
+          <a:stretch>
+            <a:fillRect/>
+          </a:stretch>
+        </p:blipFill>
+        <p:spPr>
+          <a:xfrm>
+            <a:off x="6400800" y="1417320"/>
+            <a:ext cx="1776925" cy="2331720"/>
+          </a:xfrm>
+          <a:prstGeom prst="rect">
+            <a:avLst/>
+          </a:prstGeom>
+        </p:spPr>
+      </p:pic>
+      <p:sp>
+        <p:nvSpPr>
+          <p:cNvPr id="15" name="TextBox 14"/>
+          <p:cNvSpPr txBox="1"/>
+          <p:nvPr/>
+        </p:nvSpPr>
+        <p:spPr>
+          <a:xfrm>
+            <a:off x="8366760" y="1554480"/>
+            <a:ext cx="3200400" cy="2011680"/>
           </a:xfrm>
           <a:prstGeom prst="rect">
             <a:avLst/>
@@ -12921,14 +13324,14 @@
       </p:sp>
       <p:sp>
         <p:nvSpPr>
-          <p:cNvPr id="14" name="TextBox 13"/>
-          <p:cNvSpPr txBox="1"/>
-          <p:nvPr/>
-        </p:nvSpPr>
-        <p:spPr>
-          <a:xfrm>
-            <a:off x="6336792" y="1801368"/>
-            <a:ext cx="5294376" cy="4352544"/>
+          <p:cNvPr id="16" name="TextBox 15"/>
+          <p:cNvSpPr txBox="1"/>
+          <p:nvPr/>
+        </p:nvSpPr>
+        <p:spPr>
+          <a:xfrm>
+            <a:off x="6400800" y="3840480"/>
+            <a:ext cx="5166360" cy="2286000"/>
           </a:xfrm>
           <a:prstGeom prst="rect">
             <a:avLst/>
@@ -12941,9 +13344,8 @@
           </a:bodyPr>
           <a:lstStyle/>
           <a:p>
-            <a:pPr algn="l"/>
-            <a:r>
-              <a:rPr sz="1600" b="0">
+            <a:r>
+              <a:rPr sz="1500" b="0">
                 <a:solidFill>
                   <a:srgbClr val="1C2E45"/>
                 </a:solidFill>
@@ -13254,8 +13656,8 @@
         </p:nvSpPr>
         <p:spPr>
           <a:xfrm>
-            <a:off x="365760" y="1325880"/>
-            <a:ext cx="5623560" cy="4937760"/>
+            <a:off x="365760" y="1280160"/>
+            <a:ext cx="5623560" cy="5074920"/>
           </a:xfrm>
           <a:prstGeom prst="roundRect">
             <a:avLst>
@@ -13294,16 +13696,40 @@
           </a:p>
         </p:txBody>
       </p:sp>
-      <p:sp>
-        <p:nvSpPr>
-          <p:cNvPr id="10" name="TextBox 9"/>
-          <p:cNvSpPr txBox="1"/>
-          <p:nvPr/>
-        </p:nvSpPr>
-        <p:spPr>
-          <a:xfrm>
-            <a:off x="530352" y="1453896"/>
-            <a:ext cx="5294376" cy="365760"/>
+      <p:pic>
+        <p:nvPicPr>
+          <p:cNvPr id="10" name="Picture 9" descr="flash.png"/>
+          <p:cNvPicPr>
+            <a:picLocks noChangeAspect="1"/>
+          </p:cNvPicPr>
+          <p:nvPr/>
+        </p:nvPicPr>
+        <p:blipFill>
+          <a:blip r:embed="rId2"/>
+          <a:stretch>
+            <a:fillRect/>
+          </a:stretch>
+        </p:blipFill>
+        <p:spPr>
+          <a:xfrm>
+            <a:off x="594360" y="1417320"/>
+            <a:ext cx="1310937" cy="2331720"/>
+          </a:xfrm>
+          <a:prstGeom prst="rect">
+            <a:avLst/>
+          </a:prstGeom>
+        </p:spPr>
+      </p:pic>
+      <p:sp>
+        <p:nvSpPr>
+          <p:cNvPr id="11" name="TextBox 10"/>
+          <p:cNvSpPr txBox="1"/>
+          <p:nvPr/>
+        </p:nvSpPr>
+        <p:spPr>
+          <a:xfrm>
+            <a:off x="2560320" y="1554480"/>
+            <a:ext cx="3200400" cy="2011680"/>
           </a:xfrm>
           <a:prstGeom prst="rect">
             <a:avLst/>
@@ -13331,14 +13757,14 @@
       </p:sp>
       <p:sp>
         <p:nvSpPr>
-          <p:cNvPr id="11" name="TextBox 10"/>
-          <p:cNvSpPr txBox="1"/>
-          <p:nvPr/>
-        </p:nvSpPr>
-        <p:spPr>
-          <a:xfrm>
-            <a:off x="530352" y="1801368"/>
-            <a:ext cx="5294376" cy="4352544"/>
+          <p:cNvPr id="12" name="TextBox 11"/>
+          <p:cNvSpPr txBox="1"/>
+          <p:nvPr/>
+        </p:nvSpPr>
+        <p:spPr>
+          <a:xfrm>
+            <a:off x="594360" y="3840480"/>
+            <a:ext cx="5166360" cy="2286000"/>
           </a:xfrm>
           <a:prstGeom prst="rect">
             <a:avLst/>
@@ -13351,9 +13777,8 @@
           </a:bodyPr>
           <a:lstStyle/>
           <a:p>
-            <a:pPr algn="l"/>
-            <a:r>
-              <a:rPr sz="1600" b="0">
+            <a:r>
+              <a:rPr sz="1500" b="0">
                 <a:solidFill>
                   <a:srgbClr val="1C2E45"/>
                 </a:solidFill>
@@ -13368,14 +13793,14 @@
       </p:sp>
       <p:sp>
         <p:nvSpPr>
-          <p:cNvPr id="12" name="Rounded Rectangle 11"/>
+          <p:cNvPr id="13" name="Rounded Rectangle 12"/>
           <p:cNvSpPr/>
           <p:nvPr/>
         </p:nvSpPr>
         <p:spPr>
           <a:xfrm>
-            <a:off x="6172200" y="1325880"/>
-            <a:ext cx="5623560" cy="4937760"/>
+            <a:off x="6172200" y="1280160"/>
+            <a:ext cx="5623560" cy="5074920"/>
           </a:xfrm>
           <a:prstGeom prst="roundRect">
             <a:avLst>
@@ -13414,16 +13839,40 @@
           </a:p>
         </p:txBody>
       </p:sp>
-      <p:sp>
-        <p:nvSpPr>
-          <p:cNvPr id="13" name="TextBox 12"/>
-          <p:cNvSpPr txBox="1"/>
-          <p:nvPr/>
-        </p:nvSpPr>
-        <p:spPr>
-          <a:xfrm>
-            <a:off x="6336792" y="1453896"/>
-            <a:ext cx="5294376" cy="365760"/>
+      <p:pic>
+        <p:nvPicPr>
+          <p:cNvPr id="14" name="Picture 13" descr="cc1.png"/>
+          <p:cNvPicPr>
+            <a:picLocks noChangeAspect="1"/>
+          </p:cNvPicPr>
+          <p:nvPr/>
+        </p:nvPicPr>
+        <p:blipFill>
+          <a:blip r:embed="rId3"/>
+          <a:stretch>
+            <a:fillRect/>
+          </a:stretch>
+        </p:blipFill>
+        <p:spPr>
+          <a:xfrm>
+            <a:off x="6400800" y="1417320"/>
+            <a:ext cx="1310937" cy="2331720"/>
+          </a:xfrm>
+          <a:prstGeom prst="rect">
+            <a:avLst/>
+          </a:prstGeom>
+        </p:spPr>
+      </p:pic>
+      <p:sp>
+        <p:nvSpPr>
+          <p:cNvPr id="15" name="TextBox 14"/>
+          <p:cNvSpPr txBox="1"/>
+          <p:nvPr/>
+        </p:nvSpPr>
+        <p:spPr>
+          <a:xfrm>
+            <a:off x="8366760" y="1554480"/>
+            <a:ext cx="3200400" cy="2011680"/>
           </a:xfrm>
           <a:prstGeom prst="rect">
             <a:avLst/>
@@ -13451,14 +13900,14 @@
       </p:sp>
       <p:sp>
         <p:nvSpPr>
-          <p:cNvPr id="14" name="TextBox 13"/>
-          <p:cNvSpPr txBox="1"/>
-          <p:nvPr/>
-        </p:nvSpPr>
-        <p:spPr>
-          <a:xfrm>
-            <a:off x="6336792" y="1801368"/>
-            <a:ext cx="5294376" cy="4352544"/>
+          <p:cNvPr id="16" name="TextBox 15"/>
+          <p:cNvSpPr txBox="1"/>
+          <p:nvPr/>
+        </p:nvSpPr>
+        <p:spPr>
+          <a:xfrm>
+            <a:off x="6400800" y="3840480"/>
+            <a:ext cx="5166360" cy="2286000"/>
           </a:xfrm>
           <a:prstGeom prst="rect">
             <a:avLst/>
@@ -13471,9 +13920,8 @@
           </a:bodyPr>
           <a:lstStyle/>
           <a:p>
-            <a:pPr algn="l"/>
-            <a:r>
-              <a:rPr sz="1600" b="0">
+            <a:r>
+              <a:rPr sz="1500" b="0">
                 <a:solidFill>
                   <a:srgbClr val="1C2E45"/>
                 </a:solidFill>

</xml_diff>